<commit_message>
Refresh CTC deck and publish + enrich Merch Data Agent
- Add enrich_ctc_data_agent.py: publishes the CTC Merch Data Agent (was
  draft-only with no datasource binding). Parses ctc_merch TMDL to build
  draft + published datasource.json with 7 tables, 75 columns, 64 measures,
  5 relationships, merch-specific dataSourceInstructions and per-table
  descriptions. Sets aiInstructions with POS/EGM/RVS/WoS/fill rate /
  lost-sales vocab and a Use Cases appendix.
- Refresh CTC_Merch_Copilot_Demo.pptx: insert new Data Agent slide (10
  starter prompts + status panel), update architecture lane to call out
  the Data Agent.
- .gitignore: hide CTC backup + transient API dumps.

Co-Authored-By: Claude Opus 4.7 (1M context) <noreply@anthropic.com>
</commit_message>
<xml_diff>
--- a/canadian_tire_demo/CTC_Merch_Copilot_Demo.pptx
+++ b/canadian_tire_demo/CTC_Merch_Copilot_Demo.pptx
@@ -16,6 +16,7 @@
     <p:sldId id="264" r:id="rId15"/>
     <p:sldId id="265" r:id="rId16"/>
     <p:sldId id="266" r:id="rId17"/>
+    <p:sldId id="267" r:id="rId18"/>
   </p:sldIdLst>
   <p:sldSz cx="12191695" cy="6858000" type="screen4x3"/>
   <p:notesSz cx="6858000" cy="9144000"/>
@@ -3462,7 +3463,7 @@
                 </a:solidFill>
                 <a:latin typeface="Segoe UI"/>
               </a:rPr>
-              <a:t>Recommended next steps</a:t>
+              <a:t>Roadmap</a:t>
             </a:r>
           </a:p>
         </p:txBody>
@@ -3497,7 +3498,7 @@
                 </a:solidFill>
                 <a:latin typeface="Segoe UI"/>
               </a:rPr>
-              <a:t>From demo to enterprise rollout</a:t>
+              <a:t>Where Copilot in Power BI is going</a:t>
             </a:r>
           </a:p>
         </p:txBody>
@@ -3571,7 +3572,7 @@
                 </a:solidFill>
                 <a:latin typeface="Segoe UI"/>
               </a:rPr>
-              <a:t>•  This week</a:t>
+              <a:t>•  GA today</a:t>
             </a:r>
             <a:r>
               <a:rPr sz="1200" b="0">
@@ -3580,7 +3581,7 @@
                 </a:solidFill>
                 <a:latin typeface="Segoe UI"/>
               </a:rPr>
-              <a:t>  — Enable Copilot in Power BI for the Merch team pilot workspace (IT ticket - CTC IT noted ongoing enablement)</a:t>
+              <a:t>  — Summarize page, Q&amp;A, Smart Narrative, Find Insights, anomaly explanations</a:t>
             </a:r>
           </a:p>
           <a:p>
@@ -3596,7 +3597,7 @@
                 </a:solidFill>
                 <a:latin typeface="Segoe UI"/>
               </a:rPr>
-              <a:t>•  Within 2 weeks</a:t>
+              <a:t>•  Recent additions</a:t>
             </a:r>
             <a:r>
               <a:rPr sz="1200" b="0">
@@ -3605,7 +3606,7 @@
                 </a:solidFill>
                 <a:latin typeface="Segoe UI"/>
               </a:rPr>
-              <a:t>  — Apply the descriptions / synonyms / example prompts pattern to the migrated Merch semantic models</a:t>
+              <a:t>  — Cross-report grounding, custom semantic model instructions, multi-turn Q&amp;A</a:t>
             </a:r>
           </a:p>
           <a:p>
@@ -3621,7 +3622,7 @@
                 </a:solidFill>
                 <a:latin typeface="Segoe UI"/>
               </a:rPr>
-              <a:t>•  Within 4 weeks</a:t>
+              <a:t>•  Near-term (next 90 days)</a:t>
             </a:r>
             <a:r>
               <a:rPr sz="1200" b="0">
@@ -3630,7 +3631,7 @@
                 </a:solidFill>
                 <a:latin typeface="Segoe UI"/>
               </a:rPr>
-              <a:t>  — Pilot with 10-15 buyers, capture prompt patterns, refine examplePrompts.json</a:t>
+              <a:t>  — Agent-style follow-ups, deeper drill into measure lineage, custom example prompts at workspace scope</a:t>
             </a:r>
           </a:p>
           <a:p>
@@ -3646,7 +3647,7 @@
                 </a:solidFill>
                 <a:latin typeface="Segoe UI"/>
               </a:rPr>
-              <a:t>•  ARB-2</a:t>
+              <a:t>•  Integration story</a:t>
             </a:r>
             <a:r>
               <a:rPr sz="1200" b="0">
@@ -3655,7 +3656,7 @@
                 </a:solidFill>
                 <a:latin typeface="Segoe UI"/>
               </a:rPr>
-              <a:t>  — Use this pilot evidence + governance posture for ARB-2 approval</a:t>
+              <a:t>  — Fabric Data Agent, Copilot Studio agents, Teams + Outlook + Word surfaces</a:t>
             </a:r>
           </a:p>
           <a:p>
@@ -3671,7 +3672,7 @@
                 </a:solidFill>
                 <a:latin typeface="Segoe UI"/>
               </a:rPr>
-              <a:t>•  Broader rollout</a:t>
+              <a:t>•  CTC-specific opportunities</a:t>
             </a:r>
             <a:r>
               <a:rPr sz="1200" b="0">
@@ -3680,32 +3681,7 @@
                 </a:solidFill>
                 <a:latin typeface="Segoe UI"/>
               </a:rPr>
-              <a:t>  — Cascade to Finance (separate effort), Supply Chain, Stores once Merch validates</a:t>
-            </a:r>
-          </a:p>
-          <a:p>
-            <a:pPr>
-              <a:lnSpc>
-                <a:spcPct val="115000"/>
-              </a:lnSpc>
-            </a:pPr>
-            <a:r>
-              <a:rPr sz="1300" b="1">
-                <a:solidFill>
-                  <a:srgbClr val="1B2C5C"/>
-                </a:solidFill>
-                <a:latin typeface="Segoe UI"/>
-              </a:rPr>
-              <a:t>•  Microsoft Canada support</a:t>
-            </a:r>
-            <a:r>
-              <a:rPr sz="1200" b="0">
-                <a:solidFill>
-                  <a:srgbClr val="5A6B82"/>
-                </a:solidFill>
-                <a:latin typeface="Segoe UI"/>
-              </a:rPr>
-              <a:t>  — Engineering hands-on for the first 30 days; weekly office hours for buyer Q&amp;A patterns</a:t>
+              <a:t>  — Workspace-scoped Copilot for Merch, finance-team scope (separate effort), supply-chain agent on Connected Inventory</a:t>
             </a:r>
           </a:p>
         </p:txBody>
@@ -3737,6 +3713,390 @@
         <p:spPr>
           <a:xfrm>
             <a:off x="0" y="0"/>
+            <a:ext cx="12191695" cy="777240"/>
+          </a:xfrm>
+          <a:prstGeom prst="rect">
+            <a:avLst/>
+          </a:prstGeom>
+          <a:solidFill>
+            <a:srgbClr val="FFFFFF"/>
+          </a:solidFill>
+          <a:ln>
+            <a:noFill/>
+          </a:ln>
+          <a:effectLst/>
+        </p:spPr>
+        <p:style>
+          <a:lnRef idx="1">
+            <a:schemeClr val="accent1"/>
+          </a:lnRef>
+          <a:fillRef idx="3">
+            <a:schemeClr val="accent1"/>
+          </a:fillRef>
+          <a:effectRef idx="2">
+            <a:schemeClr val="accent1"/>
+          </a:effectRef>
+          <a:fontRef idx="minor">
+            <a:schemeClr val="lt1"/>
+          </a:fontRef>
+        </p:style>
+        <p:txBody>
+          <a:bodyPr rtlCol="0" anchor="ctr"/>
+          <a:lstStyle/>
+          <a:p>
+            <a:pPr algn="ctr"/>
+          </a:p>
+        </p:txBody>
+      </p:sp>
+      <p:sp>
+        <p:nvSpPr>
+          <p:cNvPr id="3" name="Rectangle 2"/>
+          <p:cNvSpPr/>
+          <p:nvPr/>
+        </p:nvSpPr>
+        <p:spPr>
+          <a:xfrm>
+            <a:off x="0" y="777240"/>
+            <a:ext cx="12191695" cy="38100"/>
+          </a:xfrm>
+          <a:prstGeom prst="rect">
+            <a:avLst/>
+          </a:prstGeom>
+          <a:solidFill>
+            <a:srgbClr val="CA1A22"/>
+          </a:solidFill>
+          <a:ln>
+            <a:noFill/>
+          </a:ln>
+          <a:effectLst/>
+        </p:spPr>
+        <p:style>
+          <a:lnRef idx="1">
+            <a:schemeClr val="accent1"/>
+          </a:lnRef>
+          <a:fillRef idx="3">
+            <a:schemeClr val="accent1"/>
+          </a:fillRef>
+          <a:effectRef idx="2">
+            <a:schemeClr val="accent1"/>
+          </a:effectRef>
+          <a:fontRef idx="minor">
+            <a:schemeClr val="lt1"/>
+          </a:fontRef>
+        </p:style>
+        <p:txBody>
+          <a:bodyPr rtlCol="0" anchor="ctr"/>
+          <a:lstStyle/>
+          <a:p>
+            <a:pPr algn="ctr"/>
+          </a:p>
+        </p:txBody>
+      </p:sp>
+      <p:sp>
+        <p:nvSpPr>
+          <p:cNvPr id="4" name="TextBox 3"/>
+          <p:cNvSpPr txBox="1"/>
+          <p:nvPr/>
+        </p:nvSpPr>
+        <p:spPr>
+          <a:xfrm>
+            <a:off x="457200" y="164592"/>
+            <a:ext cx="10972800" cy="502920"/>
+          </a:xfrm>
+          <a:prstGeom prst="rect">
+            <a:avLst/>
+          </a:prstGeom>
+          <a:noFill/>
+        </p:spPr>
+        <p:txBody>
+          <a:bodyPr wrap="square" anchor="ctr" lIns="0" rIns="0" tIns="0" bIns="0">
+            <a:spAutoFit/>
+          </a:bodyPr>
+          <a:lstStyle/>
+          <a:p>
+            <a:pPr algn="l"/>
+            <a:r>
+              <a:rPr sz="2400" b="1">
+                <a:solidFill>
+                  <a:srgbClr val="1B2C5C"/>
+                </a:solidFill>
+                <a:latin typeface="Segoe UI"/>
+              </a:rPr>
+              <a:t>Recommended next steps</a:t>
+            </a:r>
+          </a:p>
+        </p:txBody>
+      </p:sp>
+      <p:sp>
+        <p:nvSpPr>
+          <p:cNvPr id="5" name="TextBox 4"/>
+          <p:cNvSpPr txBox="1"/>
+          <p:nvPr/>
+        </p:nvSpPr>
+        <p:spPr>
+          <a:xfrm>
+            <a:off x="457200" y="457200"/>
+            <a:ext cx="10972800" cy="320040"/>
+          </a:xfrm>
+          <a:prstGeom prst="rect">
+            <a:avLst/>
+          </a:prstGeom>
+          <a:noFill/>
+        </p:spPr>
+        <p:txBody>
+          <a:bodyPr wrap="square" anchor="t" lIns="0" rIns="0" tIns="0" bIns="0">
+            <a:spAutoFit/>
+          </a:bodyPr>
+          <a:lstStyle/>
+          <a:p>
+            <a:pPr algn="l"/>
+            <a:r>
+              <a:rPr sz="1100" b="0">
+                <a:solidFill>
+                  <a:srgbClr val="5A6B82"/>
+                </a:solidFill>
+                <a:latin typeface="Segoe UI"/>
+              </a:rPr>
+              <a:t>From demo to enterprise rollout</a:t>
+            </a:r>
+          </a:p>
+        </p:txBody>
+      </p:sp>
+      <p:sp>
+        <p:nvSpPr>
+          <p:cNvPr id="6" name="TextBox 5"/>
+          <p:cNvSpPr txBox="1"/>
+          <p:nvPr/>
+        </p:nvSpPr>
+        <p:spPr>
+          <a:xfrm>
+            <a:off x="10515600" y="228600"/>
+            <a:ext cx="1554480" cy="320040"/>
+          </a:xfrm>
+          <a:prstGeom prst="rect">
+            <a:avLst/>
+          </a:prstGeom>
+          <a:noFill/>
+        </p:spPr>
+        <p:txBody>
+          <a:bodyPr wrap="square" anchor="t" lIns="0" rIns="0" tIns="0" bIns="0">
+            <a:spAutoFit/>
+          </a:bodyPr>
+          <a:lstStyle/>
+          <a:p>
+            <a:pPr algn="r"/>
+            <a:r>
+              <a:rPr sz="900" b="0">
+                <a:solidFill>
+                  <a:srgbClr val="5A6B82"/>
+                </a:solidFill>
+                <a:latin typeface="Segoe UI"/>
+              </a:rPr>
+              <a:t>Microsoft Canada</a:t>
+            </a:r>
+          </a:p>
+        </p:txBody>
+      </p:sp>
+      <p:sp>
+        <p:nvSpPr>
+          <p:cNvPr id="7" name="TextBox 6"/>
+          <p:cNvSpPr txBox="1"/>
+          <p:nvPr/>
+        </p:nvSpPr>
+        <p:spPr>
+          <a:xfrm>
+            <a:off x="640080" y="1371600"/>
+            <a:ext cx="10972800" cy="5029200"/>
+          </a:xfrm>
+          <a:prstGeom prst="rect">
+            <a:avLst/>
+          </a:prstGeom>
+          <a:noFill/>
+        </p:spPr>
+        <p:txBody>
+          <a:bodyPr wrap="square" lIns="0" rIns="0" tIns="0" bIns="0">
+            <a:spAutoFit/>
+          </a:bodyPr>
+          <a:lstStyle/>
+          <a:p>
+            <a:pPr>
+              <a:lnSpc>
+                <a:spcPct val="115000"/>
+              </a:lnSpc>
+            </a:pPr>
+            <a:r>
+              <a:rPr sz="1300" b="1">
+                <a:solidFill>
+                  <a:srgbClr val="1B2C5C"/>
+                </a:solidFill>
+                <a:latin typeface="Segoe UI"/>
+              </a:rPr>
+              <a:t>•  This week</a:t>
+            </a:r>
+            <a:r>
+              <a:rPr sz="1200" b="0">
+                <a:solidFill>
+                  <a:srgbClr val="5A6B82"/>
+                </a:solidFill>
+                <a:latin typeface="Segoe UI"/>
+              </a:rPr>
+              <a:t>  — Enable Copilot in Power BI for the Merch team pilot workspace (IT ticket - CTC IT noted ongoing enablement)</a:t>
+            </a:r>
+          </a:p>
+          <a:p>
+            <a:pPr>
+              <a:lnSpc>
+                <a:spcPct val="115000"/>
+              </a:lnSpc>
+            </a:pPr>
+            <a:r>
+              <a:rPr sz="1300" b="1">
+                <a:solidFill>
+                  <a:srgbClr val="1B2C5C"/>
+                </a:solidFill>
+                <a:latin typeface="Segoe UI"/>
+              </a:rPr>
+              <a:t>•  Within 2 weeks</a:t>
+            </a:r>
+            <a:r>
+              <a:rPr sz="1200" b="0">
+                <a:solidFill>
+                  <a:srgbClr val="5A6B82"/>
+                </a:solidFill>
+                <a:latin typeface="Segoe UI"/>
+              </a:rPr>
+              <a:t>  — Apply the descriptions / synonyms / example prompts pattern to the migrated Merch semantic models</a:t>
+            </a:r>
+          </a:p>
+          <a:p>
+            <a:pPr>
+              <a:lnSpc>
+                <a:spcPct val="115000"/>
+              </a:lnSpc>
+            </a:pPr>
+            <a:r>
+              <a:rPr sz="1300" b="1">
+                <a:solidFill>
+                  <a:srgbClr val="1B2C5C"/>
+                </a:solidFill>
+                <a:latin typeface="Segoe UI"/>
+              </a:rPr>
+              <a:t>•  Within 4 weeks</a:t>
+            </a:r>
+            <a:r>
+              <a:rPr sz="1200" b="0">
+                <a:solidFill>
+                  <a:srgbClr val="5A6B82"/>
+                </a:solidFill>
+                <a:latin typeface="Segoe UI"/>
+              </a:rPr>
+              <a:t>  — Pilot with 10-15 buyers, capture prompt patterns, refine examplePrompts.json</a:t>
+            </a:r>
+          </a:p>
+          <a:p>
+            <a:pPr>
+              <a:lnSpc>
+                <a:spcPct val="115000"/>
+              </a:lnSpc>
+            </a:pPr>
+            <a:r>
+              <a:rPr sz="1300" b="1">
+                <a:solidFill>
+                  <a:srgbClr val="1B2C5C"/>
+                </a:solidFill>
+                <a:latin typeface="Segoe UI"/>
+              </a:rPr>
+              <a:t>•  ARB-2</a:t>
+            </a:r>
+            <a:r>
+              <a:rPr sz="1200" b="0">
+                <a:solidFill>
+                  <a:srgbClr val="5A6B82"/>
+                </a:solidFill>
+                <a:latin typeface="Segoe UI"/>
+              </a:rPr>
+              <a:t>  — Use this pilot evidence + governance posture for ARB-2 approval</a:t>
+            </a:r>
+          </a:p>
+          <a:p>
+            <a:pPr>
+              <a:lnSpc>
+                <a:spcPct val="115000"/>
+              </a:lnSpc>
+            </a:pPr>
+            <a:r>
+              <a:rPr sz="1300" b="1">
+                <a:solidFill>
+                  <a:srgbClr val="1B2C5C"/>
+                </a:solidFill>
+                <a:latin typeface="Segoe UI"/>
+              </a:rPr>
+              <a:t>•  Broader rollout</a:t>
+            </a:r>
+            <a:r>
+              <a:rPr sz="1200" b="0">
+                <a:solidFill>
+                  <a:srgbClr val="5A6B82"/>
+                </a:solidFill>
+                <a:latin typeface="Segoe UI"/>
+              </a:rPr>
+              <a:t>  — Cascade to Finance (separate effort), Supply Chain, Stores once Merch validates</a:t>
+            </a:r>
+          </a:p>
+          <a:p>
+            <a:pPr>
+              <a:lnSpc>
+                <a:spcPct val="115000"/>
+              </a:lnSpc>
+            </a:pPr>
+            <a:r>
+              <a:rPr sz="1300" b="1">
+                <a:solidFill>
+                  <a:srgbClr val="1B2C5C"/>
+                </a:solidFill>
+                <a:latin typeface="Segoe UI"/>
+              </a:rPr>
+              <a:t>•  Microsoft Canada support</a:t>
+            </a:r>
+            <a:r>
+              <a:rPr sz="1200" b="0">
+                <a:solidFill>
+                  <a:srgbClr val="5A6B82"/>
+                </a:solidFill>
+                <a:latin typeface="Segoe UI"/>
+              </a:rPr>
+              <a:t>  — Engineering hands-on for the first 30 days; weekly office hours for buyer Q&amp;A patterns</a:t>
+            </a:r>
+          </a:p>
+        </p:txBody>
+      </p:sp>
+    </p:spTree>
+  </p:cSld>
+  <p:clrMapOvr>
+    <a:masterClrMapping/>
+  </p:clrMapOvr>
+</p:sld>
+</file>
+
+<file path=ppt/slides/slide12.xml><?xml version="1.0" encoding="utf-8"?>
+<p:sld xmlns:a="http://schemas.openxmlformats.org/drawingml/2006/main" xmlns:p="http://schemas.openxmlformats.org/presentationml/2006/main" xmlns:r="http://schemas.openxmlformats.org/officeDocument/2006/relationships">
+  <p:cSld>
+    <p:spTree>
+      <p:nvGrpSpPr>
+        <p:cNvPr id="1" name=""/>
+        <p:cNvGrpSpPr/>
+        <p:nvPr/>
+      </p:nvGrpSpPr>
+      <p:grpSpPr/>
+      <p:sp>
+        <p:nvSpPr>
+          <p:cNvPr id="2" name="Rectangle 1"/>
+          <p:cNvSpPr/>
+          <p:nvPr/>
+        </p:nvSpPr>
+        <p:spPr>
+          <a:xfrm>
+            <a:off x="0" y="0"/>
             <a:ext cx="12191695" cy="6858000"/>
           </a:xfrm>
           <a:prstGeom prst="rect">
@@ -5215,7 +5575,7 @@
                 </a:solidFill>
                 <a:latin typeface="Segoe UI"/>
               </a:rPr>
-              <a:t>Copilot in Power BI  |  Smart Narrative  |  Q&amp;A  |  Data Agent</a:t>
+              <a:t>Copilot in Power BI  |  Smart Narrative  |  Q&amp;A  |  Fabric Data Agent (Teams + Portal)</a:t>
             </a:r>
           </a:p>
         </p:txBody>
@@ -5329,7 +5689,7 @@
                 </a:solidFill>
                 <a:latin typeface="Segoe UI"/>
               </a:rPr>
-              <a:t>ctc_merch (Direct Lake on OneLake) - measure descriptions, synonyms, example prompts</a:t>
+              <a:t>ctc_merch (Direct Lake on OneLake) - measure descriptions, synonyms, table semantics for the Data Agent</a:t>
             </a:r>
           </a:p>
         </p:txBody>
@@ -7557,7 +7917,7 @@
                 </a:solidFill>
                 <a:latin typeface="Segoe UI"/>
               </a:rPr>
-              <a:t>Headline findings from the demo data</a:t>
+              <a:t>CTC Merch Data Agent</a:t>
             </a:r>
           </a:p>
         </p:txBody>
@@ -7592,7 +7952,7 @@
                 </a:solidFill>
                 <a:latin typeface="Segoe UI"/>
               </a:rPr>
-              <a:t>What Copilot surfaces in seconds</a:t>
+              <a:t>Conversational analytics outside the report - in Teams, in the portal</a:t>
             </a:r>
           </a:p>
         </p:txBody>
@@ -7641,7 +8001,7 @@
         <p:spPr>
           <a:xfrm>
             <a:off x="457200" y="1280160"/>
-            <a:ext cx="2743200" cy="1463040"/>
+            <a:ext cx="5029200" cy="5120640"/>
           </a:xfrm>
           <a:prstGeom prst="rect">
             <a:avLst/>
@@ -7684,29 +8044,29 @@
         </p:nvSpPr>
         <p:spPr>
           <a:xfrm>
-            <a:off x="457200" y="1508760"/>
-            <a:ext cx="2743200" cy="640080"/>
-          </a:xfrm>
-          <a:prstGeom prst="rect">
-            <a:avLst/>
-          </a:prstGeom>
-          <a:noFill/>
-        </p:spPr>
-        <p:txBody>
-          <a:bodyPr wrap="square" anchor="ctr" lIns="0" rIns="0" tIns="0" bIns="0">
-            <a:spAutoFit/>
-          </a:bodyPr>
-          <a:lstStyle/>
-          <a:p>
-            <a:pPr algn="ctr"/>
-            <a:r>
-              <a:rPr sz="2400" b="1">
+            <a:off x="640080" y="1417320"/>
+            <a:ext cx="4663440" cy="365760"/>
+          </a:xfrm>
+          <a:prstGeom prst="rect">
+            <a:avLst/>
+          </a:prstGeom>
+          <a:noFill/>
+        </p:spPr>
+        <p:txBody>
+          <a:bodyPr wrap="square" anchor="t" lIns="0" rIns="0" tIns="0" bIns="0">
+            <a:spAutoFit/>
+          </a:bodyPr>
+          <a:lstStyle/>
+          <a:p>
+            <a:pPr algn="l"/>
+            <a:r>
+              <a:rPr sz="1500" b="1">
                 <a:solidFill>
                   <a:srgbClr val="CA1A22"/>
                 </a:solidFill>
                 <a:latin typeface="Segoe UI"/>
               </a:rPr>
-              <a:t>+27.9%</a:t>
+              <a:t>Same model, different surface</a:t>
             </a:r>
           </a:p>
         </p:txBody>
@@ -7719,8 +8079,131 @@
         </p:nvSpPr>
         <p:spPr>
           <a:xfrm>
-            <a:off x="457200" y="2240280"/>
-            <a:ext cx="2743200" cy="365760"/>
+            <a:off x="640080" y="1874519"/>
+            <a:ext cx="4663440" cy="2377440"/>
+          </a:xfrm>
+          <a:prstGeom prst="rect">
+            <a:avLst/>
+          </a:prstGeom>
+          <a:noFill/>
+        </p:spPr>
+        <p:txBody>
+          <a:bodyPr wrap="square" lIns="0" rIns="0" tIns="0" bIns="0">
+            <a:spAutoFit/>
+          </a:bodyPr>
+          <a:lstStyle/>
+          <a:p>
+            <a:pPr>
+              <a:lnSpc>
+                <a:spcPct val="115000"/>
+              </a:lnSpc>
+            </a:pPr>
+            <a:r>
+              <a:rPr sz="1200" b="1">
+                <a:solidFill>
+                  <a:srgbClr val="1B2C5C"/>
+                </a:solidFill>
+                <a:latin typeface="Segoe UI"/>
+              </a:rPr>
+              <a:t>•  Grounded on ctc_merch</a:t>
+            </a:r>
+            <a:r>
+              <a:rPr sz="1100" b="0">
+                <a:solidFill>
+                  <a:srgbClr val="5A6B82"/>
+                </a:solidFill>
+                <a:latin typeface="Segoe UI"/>
+              </a:rPr>
+              <a:t>  — Same Direct Lake model that powers the report</a:t>
+            </a:r>
+          </a:p>
+          <a:p>
+            <a:pPr>
+              <a:lnSpc>
+                <a:spcPct val="115000"/>
+              </a:lnSpc>
+            </a:pPr>
+            <a:r>
+              <a:rPr sz="1200" b="1">
+                <a:solidFill>
+                  <a:srgbClr val="1B2C5C"/>
+                </a:solidFill>
+                <a:latin typeface="Segoe UI"/>
+              </a:rPr>
+              <a:t>•  Merch vocabulary built in</a:t>
+            </a:r>
+            <a:r>
+              <a:rPr sz="1100" b="0">
+                <a:solidFill>
+                  <a:srgbClr val="5A6B82"/>
+                </a:solidFill>
+                <a:latin typeface="Segoe UI"/>
+              </a:rPr>
+              <a:t>  — POS, EGM, RVS, WoS, fill rate, lost sales, fineline</a:t>
+            </a:r>
+          </a:p>
+          <a:p>
+            <a:pPr>
+              <a:lnSpc>
+                <a:spcPct val="115000"/>
+              </a:lnSpc>
+            </a:pPr>
+            <a:r>
+              <a:rPr sz="1200" b="1">
+                <a:solidFill>
+                  <a:srgbClr val="1B2C5C"/>
+                </a:solidFill>
+                <a:latin typeface="Segoe UI"/>
+              </a:rPr>
+              <a:t>•  Use cases pre-seeded</a:t>
+            </a:r>
+            <a:r>
+              <a:rPr sz="1100" b="0">
+                <a:solidFill>
+                  <a:srgbClr val="5A6B82"/>
+                </a:solidFill>
+                <a:latin typeface="Segoe UI"/>
+              </a:rPr>
+              <a:t>  — Top SKUs by EGM, at-risk SKUs, markdown candidates, vendor summary</a:t>
+            </a:r>
+          </a:p>
+          <a:p>
+            <a:pPr>
+              <a:lnSpc>
+                <a:spcPct val="115000"/>
+              </a:lnSpc>
+            </a:pPr>
+            <a:r>
+              <a:rPr sz="1200" b="1">
+                <a:solidFill>
+                  <a:srgbClr val="1B2C5C"/>
+                </a:solidFill>
+                <a:latin typeface="Segoe UI"/>
+              </a:rPr>
+              <a:t>•  Lives where buyers work</a:t>
+            </a:r>
+            <a:r>
+              <a:rPr sz="1100" b="0">
+                <a:solidFill>
+                  <a:srgbClr val="5A6B82"/>
+                </a:solidFill>
+                <a:latin typeface="Segoe UI"/>
+              </a:rPr>
+              <a:t>  — Fabric portal today; Teams + Copilot Studio next</a:t>
+            </a:r>
+          </a:p>
+        </p:txBody>
+      </p:sp>
+      <p:sp>
+        <p:nvSpPr>
+          <p:cNvPr id="10" name="TextBox 9"/>
+          <p:cNvSpPr txBox="1"/>
+          <p:nvPr/>
+        </p:nvSpPr>
+        <p:spPr>
+          <a:xfrm>
+            <a:off x="640080" y="4937760"/>
+            <a:ext cx="4663440" cy="365760"/>
           </a:xfrm>
           <a:prstGeom prst="rect">
             <a:avLst/>
@@ -7733,29 +8216,64 @@
           </a:bodyPr>
           <a:lstStyle/>
           <a:p>
-            <a:pPr algn="ctr"/>
-            <a:r>
-              <a:rPr sz="1100" b="0">
+            <a:pPr algn="l"/>
+            <a:r>
+              <a:rPr sz="1000" b="0">
                 <a:solidFill>
                   <a:srgbClr val="5A6B82"/>
                 </a:solidFill>
                 <a:latin typeface="Segoe UI"/>
               </a:rPr>
-              <a:t>POS YoY (Total)</a:t>
-            </a:r>
-          </a:p>
-        </p:txBody>
-      </p:sp>
-      <p:sp>
-        <p:nvSpPr>
-          <p:cNvPr id="10" name="Rectangle 9"/>
+              <a:t>Status: published, draft + published stages bound, 5 relationships indexed</a:t>
+            </a:r>
+          </a:p>
+        </p:txBody>
+      </p:sp>
+      <p:sp>
+        <p:nvSpPr>
+          <p:cNvPr id="11" name="TextBox 10"/>
+          <p:cNvSpPr txBox="1"/>
+          <p:nvPr/>
+        </p:nvSpPr>
+        <p:spPr>
+          <a:xfrm>
+            <a:off x="640080" y="5349240"/>
+            <a:ext cx="4663440" cy="365760"/>
+          </a:xfrm>
+          <a:prstGeom prst="rect">
+            <a:avLst/>
+          </a:prstGeom>
+          <a:noFill/>
+        </p:spPr>
+        <p:txBody>
+          <a:bodyPr wrap="square" anchor="t" lIns="0" rIns="0" tIns="0" bIns="0">
+            <a:spAutoFit/>
+          </a:bodyPr>
+          <a:lstStyle/>
+          <a:p>
+            <a:pPr algn="l"/>
+            <a:r>
+              <a:rPr sz="1000" b="0">
+                <a:solidFill>
+                  <a:srgbClr val="5A6B82"/>
+                </a:solidFill>
+                <a:latin typeface="Segoe UI"/>
+              </a:rPr>
+              <a:t>7 tables - 75 columns - 64 measures - all annotated</a:t>
+            </a:r>
+          </a:p>
+        </p:txBody>
+      </p:sp>
+      <p:sp>
+        <p:nvSpPr>
+          <p:cNvPr id="12" name="Rectangle 11"/>
           <p:cNvSpPr/>
           <p:nvPr/>
         </p:nvSpPr>
         <p:spPr>
           <a:xfrm>
-            <a:off x="3337560" y="1280160"/>
-            <a:ext cx="2743200" cy="1463040"/>
+            <a:off x="5623560" y="1280160"/>
+            <a:ext cx="6126480" cy="5120640"/>
           </a:xfrm>
           <a:prstGeom prst="rect">
             <a:avLst/>
@@ -7792,49 +8310,14 @@
       </p:sp>
       <p:sp>
         <p:nvSpPr>
-          <p:cNvPr id="11" name="TextBox 10"/>
-          <p:cNvSpPr txBox="1"/>
-          <p:nvPr/>
-        </p:nvSpPr>
-        <p:spPr>
-          <a:xfrm>
-            <a:off x="3337560" y="1508760"/>
-            <a:ext cx="2743200" cy="640080"/>
-          </a:xfrm>
-          <a:prstGeom prst="rect">
-            <a:avLst/>
-          </a:prstGeom>
-          <a:noFill/>
-        </p:spPr>
-        <p:txBody>
-          <a:bodyPr wrap="square" anchor="ctr" lIns="0" rIns="0" tIns="0" bIns="0">
-            <a:spAutoFit/>
-          </a:bodyPr>
-          <a:lstStyle/>
-          <a:p>
-            <a:pPr algn="ctr"/>
-            <a:r>
-              <a:rPr sz="2400" b="1">
-                <a:solidFill>
-                  <a:srgbClr val="107752"/>
-                </a:solidFill>
-                <a:latin typeface="Segoe UI"/>
-              </a:rPr>
-              <a:t>42.3%</a:t>
-            </a:r>
-          </a:p>
-        </p:txBody>
-      </p:sp>
-      <p:sp>
-        <p:nvSpPr>
-          <p:cNvPr id="12" name="TextBox 11"/>
-          <p:cNvSpPr txBox="1"/>
-          <p:nvPr/>
-        </p:nvSpPr>
-        <p:spPr>
-          <a:xfrm>
-            <a:off x="3337560" y="2240280"/>
-            <a:ext cx="2743200" cy="365760"/>
+          <p:cNvPr id="13" name="TextBox 12"/>
+          <p:cNvSpPr txBox="1"/>
+          <p:nvPr/>
+        </p:nvSpPr>
+        <p:spPr>
+          <a:xfrm>
+            <a:off x="5806440" y="1417320"/>
+            <a:ext cx="5760720" cy="365760"/>
           </a:xfrm>
           <a:prstGeom prst="rect">
             <a:avLst/>
@@ -7847,60 +8330,16 @@
           </a:bodyPr>
           <a:lstStyle/>
           <a:p>
-            <a:pPr algn="ctr"/>
-            <a:r>
-              <a:rPr sz="1100" b="0">
-                <a:solidFill>
-                  <a:srgbClr val="5A6B82"/>
-                </a:solidFill>
-                <a:latin typeface="Segoe UI"/>
-              </a:rPr>
-              <a:t>EGM % TY</a:t>
-            </a:r>
-          </a:p>
-        </p:txBody>
-      </p:sp>
-      <p:sp>
-        <p:nvSpPr>
-          <p:cNvPr id="13" name="Rectangle 12"/>
-          <p:cNvSpPr/>
-          <p:nvPr/>
-        </p:nvSpPr>
-        <p:spPr>
-          <a:xfrm>
-            <a:off x="6217920" y="1280160"/>
-            <a:ext cx="2743200" cy="1463040"/>
-          </a:xfrm>
-          <a:prstGeom prst="rect">
-            <a:avLst/>
-          </a:prstGeom>
-          <a:solidFill>
-            <a:srgbClr val="F5F6F8"/>
-          </a:solidFill>
-          <a:ln>
-            <a:noFill/>
-          </a:ln>
-          <a:effectLst/>
-        </p:spPr>
-        <p:style>
-          <a:lnRef idx="1">
-            <a:schemeClr val="accent1"/>
-          </a:lnRef>
-          <a:fillRef idx="3">
-            <a:schemeClr val="accent1"/>
-          </a:fillRef>
-          <a:effectRef idx="2">
-            <a:schemeClr val="accent1"/>
-          </a:effectRef>
-          <a:fontRef idx="minor">
-            <a:schemeClr val="lt1"/>
-          </a:fontRef>
-        </p:style>
-        <p:txBody>
-          <a:bodyPr rtlCol="0" anchor="ctr"/>
-          <a:lstStyle/>
-          <a:p>
-            <a:pPr algn="ctr"/>
+            <a:pPr algn="l"/>
+            <a:r>
+              <a:rPr sz="1500" b="1">
+                <a:solidFill>
+                  <a:srgbClr val="CA1A22"/>
+                </a:solidFill>
+                <a:latin typeface="Segoe UI"/>
+              </a:rPr>
+              <a:t>10 Starter Questions buyers can run today</a:t>
+            </a:r>
           </a:p>
         </p:txBody>
       </p:sp>
@@ -7912,29 +8351,29 @@
         </p:nvSpPr>
         <p:spPr>
           <a:xfrm>
-            <a:off x="6217920" y="1508760"/>
-            <a:ext cx="2743200" cy="640080"/>
-          </a:xfrm>
-          <a:prstGeom prst="rect">
-            <a:avLst/>
-          </a:prstGeom>
-          <a:noFill/>
-        </p:spPr>
-        <p:txBody>
-          <a:bodyPr wrap="square" anchor="ctr" lIns="0" rIns="0" tIns="0" bIns="0">
-            <a:spAutoFit/>
-          </a:bodyPr>
-          <a:lstStyle/>
-          <a:p>
-            <a:pPr algn="ctr"/>
-            <a:r>
-              <a:rPr sz="2400" b="1">
-                <a:solidFill>
-                  <a:srgbClr val="CC8A00"/>
-                </a:solidFill>
-                <a:latin typeface="Segoe UI"/>
-              </a:rPr>
-              <a:t>4.06%</a:t>
+            <a:off x="5806440" y="1874519"/>
+            <a:ext cx="365760" cy="274320"/>
+          </a:xfrm>
+          <a:prstGeom prst="rect">
+            <a:avLst/>
+          </a:prstGeom>
+          <a:noFill/>
+        </p:spPr>
+        <p:txBody>
+          <a:bodyPr wrap="square" anchor="t" lIns="0" rIns="0" tIns="0" bIns="0">
+            <a:spAutoFit/>
+          </a:bodyPr>
+          <a:lstStyle/>
+          <a:p>
+            <a:pPr algn="l"/>
+            <a:r>
+              <a:rPr sz="1000" b="1">
+                <a:solidFill>
+                  <a:srgbClr val="CA1A22"/>
+                </a:solidFill>
+                <a:latin typeface="Segoe UI"/>
+              </a:rPr>
+              <a:t>01</a:t>
             </a:r>
           </a:p>
         </p:txBody>
@@ -7947,8 +8386,8 @@
         </p:nvSpPr>
         <p:spPr>
           <a:xfrm>
-            <a:off x="6217920" y="2240280"/>
-            <a:ext cx="2743200" cy="365760"/>
+            <a:off x="6172200" y="1874519"/>
+            <a:ext cx="5394960" cy="274320"/>
           </a:xfrm>
           <a:prstGeom prst="rect">
             <a:avLst/>
@@ -7961,60 +8400,51 @@
           </a:bodyPr>
           <a:lstStyle/>
           <a:p>
-            <a:pPr algn="ctr"/>
-            <a:r>
-              <a:rPr sz="1100" b="0">
-                <a:solidFill>
-                  <a:srgbClr val="5A6B82"/>
-                </a:solidFill>
-                <a:latin typeface="Segoe UI"/>
-              </a:rPr>
-              <a:t>Avg Lost Sales</a:t>
-            </a:r>
-          </a:p>
-        </p:txBody>
-      </p:sp>
-      <p:sp>
-        <p:nvSpPr>
-          <p:cNvPr id="16" name="Rectangle 15"/>
-          <p:cNvSpPr/>
-          <p:nvPr/>
-        </p:nvSpPr>
-        <p:spPr>
-          <a:xfrm>
-            <a:off x="9098280" y="1280160"/>
-            <a:ext cx="2743200" cy="1463040"/>
-          </a:xfrm>
-          <a:prstGeom prst="rect">
-            <a:avLst/>
-          </a:prstGeom>
-          <a:solidFill>
-            <a:srgbClr val="F5F6F8"/>
-          </a:solidFill>
-          <a:ln>
-            <a:noFill/>
-          </a:ln>
-          <a:effectLst/>
-        </p:spPr>
-        <p:style>
-          <a:lnRef idx="1">
-            <a:schemeClr val="accent1"/>
-          </a:lnRef>
-          <a:fillRef idx="3">
-            <a:schemeClr val="accent1"/>
-          </a:fillRef>
-          <a:effectRef idx="2">
-            <a:schemeClr val="accent1"/>
-          </a:effectRef>
-          <a:fontRef idx="minor">
-            <a:schemeClr val="lt1"/>
-          </a:fontRef>
-        </p:style>
-        <p:txBody>
-          <a:bodyPr rtlCol="0" anchor="ctr"/>
-          <a:lstStyle/>
-          <a:p>
-            <a:pPr algn="ctr"/>
+            <a:pPr algn="l"/>
+            <a:r>
+              <a:rPr sz="1000" b="0">
+                <a:solidFill>
+                  <a:srgbClr val="1B2C5C"/>
+                </a:solidFill>
+                <a:latin typeface="Segoe UI"/>
+              </a:rPr>
+              <a:t>One-paragraph merch briefing - POS YoY, EGM %, growth and drag</a:t>
+            </a:r>
+          </a:p>
+        </p:txBody>
+      </p:sp>
+      <p:sp>
+        <p:nvSpPr>
+          <p:cNvPr id="16" name="TextBox 15"/>
+          <p:cNvSpPr txBox="1"/>
+          <p:nvPr/>
+        </p:nvSpPr>
+        <p:spPr>
+          <a:xfrm>
+            <a:off x="5806440" y="2295143"/>
+            <a:ext cx="365760" cy="274320"/>
+          </a:xfrm>
+          <a:prstGeom prst="rect">
+            <a:avLst/>
+          </a:prstGeom>
+          <a:noFill/>
+        </p:spPr>
+        <p:txBody>
+          <a:bodyPr wrap="square" anchor="t" lIns="0" rIns="0" tIns="0" bIns="0">
+            <a:spAutoFit/>
+          </a:bodyPr>
+          <a:lstStyle/>
+          <a:p>
+            <a:pPr algn="l"/>
+            <a:r>
+              <a:rPr sz="1000" b="1">
+                <a:solidFill>
+                  <a:srgbClr val="CA1A22"/>
+                </a:solidFill>
+                <a:latin typeface="Segoe UI"/>
+              </a:rPr>
+              <a:t>02</a:t>
+            </a:r>
           </a:p>
         </p:txBody>
       </p:sp>
@@ -8026,43 +8456,78 @@
         </p:nvSpPr>
         <p:spPr>
           <a:xfrm>
-            <a:off x="9098280" y="1508760"/>
-            <a:ext cx="2743200" cy="640080"/>
-          </a:xfrm>
-          <a:prstGeom prst="rect">
-            <a:avLst/>
-          </a:prstGeom>
-          <a:noFill/>
-        </p:spPr>
-        <p:txBody>
-          <a:bodyPr wrap="square" anchor="ctr" lIns="0" rIns="0" tIns="0" bIns="0">
-            <a:spAutoFit/>
-          </a:bodyPr>
-          <a:lstStyle/>
-          <a:p>
-            <a:pPr algn="ctr"/>
-            <a:r>
-              <a:rPr sz="2400" b="1">
+            <a:off x="6172200" y="2295143"/>
+            <a:ext cx="5394960" cy="274320"/>
+          </a:xfrm>
+          <a:prstGeom prst="rect">
+            <a:avLst/>
+          </a:prstGeom>
+          <a:noFill/>
+        </p:spPr>
+        <p:txBody>
+          <a:bodyPr wrap="square" anchor="t" lIns="0" rIns="0" tIns="0" bIns="0">
+            <a:spAutoFit/>
+          </a:bodyPr>
+          <a:lstStyle/>
+          <a:p>
+            <a:pPr algn="l"/>
+            <a:r>
+              <a:rPr sz="1000" b="0">
+                <a:solidFill>
+                  <a:srgbClr val="1B2C5C"/>
+                </a:solidFill>
+                <a:latin typeface="Segoe UI"/>
+              </a:rPr>
+              <a:t>Top 10 SKUs by EGM dollars with POS YoY and EGM %</a:t>
+            </a:r>
+          </a:p>
+        </p:txBody>
+      </p:sp>
+      <p:sp>
+        <p:nvSpPr>
+          <p:cNvPr id="18" name="TextBox 17"/>
+          <p:cNvSpPr txBox="1"/>
+          <p:nvPr/>
+        </p:nvSpPr>
+        <p:spPr>
+          <a:xfrm>
+            <a:off x="5806440" y="2715767"/>
+            <a:ext cx="365760" cy="274320"/>
+          </a:xfrm>
+          <a:prstGeom prst="rect">
+            <a:avLst/>
+          </a:prstGeom>
+          <a:noFill/>
+        </p:spPr>
+        <p:txBody>
+          <a:bodyPr wrap="square" anchor="t" lIns="0" rIns="0" tIns="0" bIns="0">
+            <a:spAutoFit/>
+          </a:bodyPr>
+          <a:lstStyle/>
+          <a:p>
+            <a:pPr algn="l"/>
+            <a:r>
+              <a:rPr sz="1000" b="1">
                 <a:solidFill>
                   <a:srgbClr val="CA1A22"/>
                 </a:solidFill>
                 <a:latin typeface="Segoe UI"/>
               </a:rPr>
-              <a:t>89.0%</a:t>
-            </a:r>
-          </a:p>
-        </p:txBody>
-      </p:sp>
-      <p:sp>
-        <p:nvSpPr>
-          <p:cNvPr id="18" name="TextBox 17"/>
-          <p:cNvSpPr txBox="1"/>
-          <p:nvPr/>
-        </p:nvSpPr>
-        <p:spPr>
-          <a:xfrm>
-            <a:off x="9098280" y="2240280"/>
-            <a:ext cx="2743200" cy="365760"/>
+              <a:t>03</a:t>
+            </a:r>
+          </a:p>
+        </p:txBody>
+      </p:sp>
+      <p:sp>
+        <p:nvSpPr>
+          <p:cNvPr id="19" name="TextBox 18"/>
+          <p:cNvSpPr txBox="1"/>
+          <p:nvPr/>
+        </p:nvSpPr>
+        <p:spPr>
+          <a:xfrm>
+            <a:off x="6172200" y="2715767"/>
+            <a:ext cx="5394960" cy="274320"/>
           </a:xfrm>
           <a:prstGeom prst="rect">
             <a:avLst/>
@@ -8075,29 +8540,29 @@
           </a:bodyPr>
           <a:lstStyle/>
           <a:p>
-            <a:pPr algn="ctr"/>
-            <a:r>
-              <a:rPr sz="1100" b="0">
-                <a:solidFill>
-                  <a:srgbClr val="5A6B82"/>
-                </a:solidFill>
-                <a:latin typeface="Segoe UI"/>
-              </a:rPr>
-              <a:t>Vendor Fill Rate</a:t>
-            </a:r>
-          </a:p>
-        </p:txBody>
-      </p:sp>
-      <p:sp>
-        <p:nvSpPr>
-          <p:cNvPr id="19" name="TextBox 18"/>
-          <p:cNvSpPr txBox="1"/>
-          <p:nvPr/>
-        </p:nvSpPr>
-        <p:spPr>
-          <a:xfrm>
-            <a:off x="457200" y="2926080"/>
-            <a:ext cx="11247120" cy="365760"/>
+            <a:pPr algn="l"/>
+            <a:r>
+              <a:rPr sz="1000" b="0">
+                <a:solidFill>
+                  <a:srgbClr val="1B2C5C"/>
+                </a:solidFill>
+                <a:latin typeface="Segoe UI"/>
+              </a:rPr>
+              <a:t>Air Fryers vs Cookware Sets - POS YoY and EGM %</a:t>
+            </a:r>
+          </a:p>
+        </p:txBody>
+      </p:sp>
+      <p:sp>
+        <p:nvSpPr>
+          <p:cNvPr id="20" name="TextBox 19"/>
+          <p:cNvSpPr txBox="1"/>
+          <p:nvPr/>
+        </p:nvSpPr>
+        <p:spPr>
+          <a:xfrm>
+            <a:off x="5806440" y="3136391"/>
+            <a:ext cx="365760" cy="274320"/>
           </a:xfrm>
           <a:prstGeom prst="rect">
             <a:avLst/>
@@ -8112,161 +8577,468 @@
           <a:p>
             <a:pPr algn="l"/>
             <a:r>
-              <a:rPr sz="1400" b="1">
+              <a:rPr sz="1000" b="1">
                 <a:solidFill>
                   <a:srgbClr val="CA1A22"/>
                 </a:solidFill>
                 <a:latin typeface="Segoe UI"/>
               </a:rPr>
-              <a:t>Insights merchants can act on</a:t>
-            </a:r>
-          </a:p>
-        </p:txBody>
-      </p:sp>
-      <p:sp>
-        <p:nvSpPr>
-          <p:cNvPr id="20" name="TextBox 19"/>
-          <p:cNvSpPr txBox="1"/>
-          <p:nvPr/>
-        </p:nvSpPr>
-        <p:spPr>
-          <a:xfrm>
-            <a:off x="457200" y="3337560"/>
-            <a:ext cx="11247120" cy="3200400"/>
-          </a:xfrm>
-          <a:prstGeom prst="rect">
-            <a:avLst/>
-          </a:prstGeom>
-          <a:noFill/>
-        </p:spPr>
-        <p:txBody>
-          <a:bodyPr wrap="square" lIns="0" rIns="0" tIns="0" bIns="0">
-            <a:spAutoFit/>
-          </a:bodyPr>
-          <a:lstStyle/>
-          <a:p>
-            <a:pPr>
-              <a:lnSpc>
-                <a:spcPct val="115000"/>
-              </a:lnSpc>
-            </a:pPr>
-            <a:r>
-              <a:rPr sz="1200" b="1">
+              <a:t>04</a:t>
+            </a:r>
+          </a:p>
+        </p:txBody>
+      </p:sp>
+      <p:sp>
+        <p:nvSpPr>
+          <p:cNvPr id="21" name="TextBox 20"/>
+          <p:cNvSpPr txBox="1"/>
+          <p:nvPr/>
+        </p:nvSpPr>
+        <p:spPr>
+          <a:xfrm>
+            <a:off x="6172200" y="3136391"/>
+            <a:ext cx="5394960" cy="274320"/>
+          </a:xfrm>
+          <a:prstGeom prst="rect">
+            <a:avLst/>
+          </a:prstGeom>
+          <a:noFill/>
+        </p:spPr>
+        <p:txBody>
+          <a:bodyPr wrap="square" anchor="t" lIns="0" rIns="0" tIns="0" bIns="0">
+            <a:spAutoFit/>
+          </a:bodyPr>
+          <a:lstStyle/>
+          <a:p>
+            <a:pPr algn="l"/>
+            <a:r>
+              <a:rPr sz="1000" b="0">
                 <a:solidFill>
                   <a:srgbClr val="1B2C5C"/>
                 </a:solidFill>
                 <a:latin typeface="Segoe UI"/>
               </a:rPr>
-              <a:t>•  Air Fryers +88.7% YoY POS</a:t>
-            </a:r>
-            <a:r>
-              <a:rPr sz="1100" b="0">
-                <a:solidFill>
-                  <a:srgbClr val="5A6B82"/>
-                </a:solidFill>
-                <a:latin typeface="Segoe UI"/>
-              </a:rPr>
-              <a:t>  — Strongest growth fineline - protect supply, expand assortment</a:t>
-            </a:r>
-          </a:p>
-          <a:p>
-            <a:pPr>
-              <a:lnSpc>
-                <a:spcPct val="115000"/>
-              </a:lnSpc>
-            </a:pPr>
-            <a:r>
-              <a:rPr sz="1200" b="1">
+              <a:t>SKUs with lost sales &gt; 5% AND fill rate &lt; 85%</a:t>
+            </a:r>
+          </a:p>
+        </p:txBody>
+      </p:sp>
+      <p:sp>
+        <p:nvSpPr>
+          <p:cNvPr id="22" name="TextBox 21"/>
+          <p:cNvSpPr txBox="1"/>
+          <p:nvPr/>
+        </p:nvSpPr>
+        <p:spPr>
+          <a:xfrm>
+            <a:off x="5806440" y="3557015"/>
+            <a:ext cx="365760" cy="274320"/>
+          </a:xfrm>
+          <a:prstGeom prst="rect">
+            <a:avLst/>
+          </a:prstGeom>
+          <a:noFill/>
+        </p:spPr>
+        <p:txBody>
+          <a:bodyPr wrap="square" anchor="t" lIns="0" rIns="0" tIns="0" bIns="0">
+            <a:spAutoFit/>
+          </a:bodyPr>
+          <a:lstStyle/>
+          <a:p>
+            <a:pPr algn="l"/>
+            <a:r>
+              <a:rPr sz="1000" b="1">
+                <a:solidFill>
+                  <a:srgbClr val="CA1A22"/>
+                </a:solidFill>
+                <a:latin typeface="Segoe UI"/>
+              </a:rPr>
+              <a:t>05</a:t>
+            </a:r>
+          </a:p>
+        </p:txBody>
+      </p:sp>
+      <p:sp>
+        <p:nvSpPr>
+          <p:cNvPr id="23" name="TextBox 22"/>
+          <p:cNvSpPr txBox="1"/>
+          <p:nvPr/>
+        </p:nvSpPr>
+        <p:spPr>
+          <a:xfrm>
+            <a:off x="6172200" y="3557015"/>
+            <a:ext cx="5394960" cy="274320"/>
+          </a:xfrm>
+          <a:prstGeom prst="rect">
+            <a:avLst/>
+          </a:prstGeom>
+          <a:noFill/>
+        </p:spPr>
+        <p:txBody>
+          <a:bodyPr wrap="square" anchor="t" lIns="0" rIns="0" tIns="0" bIns="0">
+            <a:spAutoFit/>
+          </a:bodyPr>
+          <a:lstStyle/>
+          <a:p>
+            <a:pPr algn="l"/>
+            <a:r>
+              <a:rPr sz="1000" b="0">
                 <a:solidFill>
                   <a:srgbClr val="1B2C5C"/>
                 </a:solidFill>
                 <a:latin typeface="Segoe UI"/>
               </a:rPr>
-              <a:t>•  NK Dual Zone Air Fryer 8L losing 13.7% of demand</a:t>
-            </a:r>
-            <a:r>
-              <a:rPr sz="1100" b="0">
-                <a:solidFill>
-                  <a:srgbClr val="5A6B82"/>
-                </a:solidFill>
-                <a:latin typeface="Segoe UI"/>
-              </a:rPr>
-              <a:t>  — Vendor fill rate only 72.7% - immediate supply intervention</a:t>
-            </a:r>
-          </a:p>
-          <a:p>
-            <a:pPr>
-              <a:lnSpc>
-                <a:spcPct val="115000"/>
-              </a:lnSpc>
-            </a:pPr>
-            <a:r>
-              <a:rPr sz="1200" b="1">
+              <a:t>WoS &gt; 18 AND lost sales &lt; 2% - markdown candidates</a:t>
+            </a:r>
+          </a:p>
+        </p:txBody>
+      </p:sp>
+      <p:sp>
+        <p:nvSpPr>
+          <p:cNvPr id="24" name="TextBox 23"/>
+          <p:cNvSpPr txBox="1"/>
+          <p:nvPr/>
+        </p:nvSpPr>
+        <p:spPr>
+          <a:xfrm>
+            <a:off x="5806440" y="3977639"/>
+            <a:ext cx="365760" cy="274320"/>
+          </a:xfrm>
+          <a:prstGeom prst="rect">
+            <a:avLst/>
+          </a:prstGeom>
+          <a:noFill/>
+        </p:spPr>
+        <p:txBody>
+          <a:bodyPr wrap="square" anchor="t" lIns="0" rIns="0" tIns="0" bIns="0">
+            <a:spAutoFit/>
+          </a:bodyPr>
+          <a:lstStyle/>
+          <a:p>
+            <a:pPr algn="l"/>
+            <a:r>
+              <a:rPr sz="1000" b="1">
+                <a:solidFill>
+                  <a:srgbClr val="CA1A22"/>
+                </a:solidFill>
+                <a:latin typeface="Segoe UI"/>
+              </a:rPr>
+              <a:t>06</a:t>
+            </a:r>
+          </a:p>
+        </p:txBody>
+      </p:sp>
+      <p:sp>
+        <p:nvSpPr>
+          <p:cNvPr id="25" name="TextBox 24"/>
+          <p:cNvSpPr txBox="1"/>
+          <p:nvPr/>
+        </p:nvSpPr>
+        <p:spPr>
+          <a:xfrm>
+            <a:off x="6172200" y="3977639"/>
+            <a:ext cx="5394960" cy="274320"/>
+          </a:xfrm>
+          <a:prstGeom prst="rect">
+            <a:avLst/>
+          </a:prstGeom>
+          <a:noFill/>
+        </p:spPr>
+        <p:txBody>
+          <a:bodyPr wrap="square" anchor="t" lIns="0" rIns="0" tIns="0" bIns="0">
+            <a:spAutoFit/>
+          </a:bodyPr>
+          <a:lstStyle/>
+          <a:p>
+            <a:pPr algn="l"/>
+            <a:r>
+              <a:rPr sz="1000" b="0">
                 <a:solidFill>
                   <a:srgbClr val="1B2C5C"/>
                 </a:solidFill>
                 <a:latin typeface="Segoe UI"/>
               </a:rPr>
-              <a:t>•  9 SKUs WoS &gt; 18 with low lost sales</a:t>
-            </a:r>
-            <a:r>
-              <a:rPr sz="1100" b="0">
-                <a:solidFill>
-                  <a:srgbClr val="5A6B82"/>
-                </a:solidFill>
-                <a:latin typeface="Segoe UI"/>
-              </a:rPr>
-              <a:t>  — Classic markdown / promo candidates - sell-through stalled</a:t>
-            </a:r>
-          </a:p>
-          <a:p>
-            <a:pPr>
-              <a:lnSpc>
-                <a:spcPct val="115000"/>
-              </a:lnSpc>
-            </a:pPr>
-            <a:r>
-              <a:rPr sz="1200" b="1">
+              <a:t>Canvas Outdoor vendor - POS, fill rate, EGM contribution</a:t>
+            </a:r>
+          </a:p>
+        </p:txBody>
+      </p:sp>
+      <p:sp>
+        <p:nvSpPr>
+          <p:cNvPr id="26" name="TextBox 25"/>
+          <p:cNvSpPr txBox="1"/>
+          <p:nvPr/>
+        </p:nvSpPr>
+        <p:spPr>
+          <a:xfrm>
+            <a:off x="5806440" y="4398263"/>
+            <a:ext cx="365760" cy="274320"/>
+          </a:xfrm>
+          <a:prstGeom prst="rect">
+            <a:avLst/>
+          </a:prstGeom>
+          <a:noFill/>
+        </p:spPr>
+        <p:txBody>
+          <a:bodyPr wrap="square" anchor="t" lIns="0" rIns="0" tIns="0" bIns="0">
+            <a:spAutoFit/>
+          </a:bodyPr>
+          <a:lstStyle/>
+          <a:p>
+            <a:pPr algn="l"/>
+            <a:r>
+              <a:rPr sz="1000" b="1">
+                <a:solidFill>
+                  <a:srgbClr val="CA1A22"/>
+                </a:solidFill>
+                <a:latin typeface="Segoe UI"/>
+              </a:rPr>
+              <a:t>07</a:t>
+            </a:r>
+          </a:p>
+        </p:txBody>
+      </p:sp>
+      <p:sp>
+        <p:nvSpPr>
+          <p:cNvPr id="27" name="TextBox 26"/>
+          <p:cNvSpPr txBox="1"/>
+          <p:nvPr/>
+        </p:nvSpPr>
+        <p:spPr>
+          <a:xfrm>
+            <a:off x="6172200" y="4398263"/>
+            <a:ext cx="5394960" cy="274320"/>
+          </a:xfrm>
+          <a:prstGeom prst="rect">
+            <a:avLst/>
+          </a:prstGeom>
+          <a:noFill/>
+        </p:spPr>
+        <p:txBody>
+          <a:bodyPr wrap="square" anchor="t" lIns="0" rIns="0" tIns="0" bIns="0">
+            <a:spAutoFit/>
+          </a:bodyPr>
+          <a:lstStyle/>
+          <a:p>
+            <a:pPr algn="l"/>
+            <a:r>
+              <a:rPr sz="1000" b="0">
                 <a:solidFill>
                   <a:srgbClr val="1B2C5C"/>
                 </a:solidFill>
                 <a:latin typeface="Segoe UI"/>
               </a:rPr>
-              <a:t>•  OL-BBQ-003 (Woodfire Grill) +1671% YoY</a:t>
-            </a:r>
-            <a:r>
-              <a:rPr sz="1100" b="0">
-                <a:solidFill>
-                  <a:srgbClr val="5A6B82"/>
-                </a:solidFill>
-                <a:latin typeface="Segoe UI"/>
-              </a:rPr>
-              <a:t>  — New SKU with strong demand but fill rate 71% - over-rotate on PO</a:t>
-            </a:r>
-          </a:p>
-          <a:p>
-            <a:pPr>
-              <a:lnSpc>
-                <a:spcPct val="115000"/>
-              </a:lnSpc>
-            </a:pPr>
-            <a:r>
-              <a:rPr sz="1200" b="1">
+              <a:t>New SKUs (New_SKU_Flag = Yes) driving the most POS growth</a:t>
+            </a:r>
+          </a:p>
+        </p:txBody>
+      </p:sp>
+      <p:sp>
+        <p:nvSpPr>
+          <p:cNvPr id="28" name="TextBox 27"/>
+          <p:cNvSpPr txBox="1"/>
+          <p:nvPr/>
+        </p:nvSpPr>
+        <p:spPr>
+          <a:xfrm>
+            <a:off x="5806440" y="4818887"/>
+            <a:ext cx="365760" cy="274320"/>
+          </a:xfrm>
+          <a:prstGeom prst="rect">
+            <a:avLst/>
+          </a:prstGeom>
+          <a:noFill/>
+        </p:spPr>
+        <p:txBody>
+          <a:bodyPr wrap="square" anchor="t" lIns="0" rIns="0" tIns="0" bIns="0">
+            <a:spAutoFit/>
+          </a:bodyPr>
+          <a:lstStyle/>
+          <a:p>
+            <a:pPr algn="l"/>
+            <a:r>
+              <a:rPr sz="1000" b="1">
+                <a:solidFill>
+                  <a:srgbClr val="CA1A22"/>
+                </a:solidFill>
+                <a:latin typeface="Segoe UI"/>
+              </a:rPr>
+              <a:t>08</a:t>
+            </a:r>
+          </a:p>
+        </p:txBody>
+      </p:sp>
+      <p:sp>
+        <p:nvSpPr>
+          <p:cNvPr id="29" name="TextBox 28"/>
+          <p:cNvSpPr txBox="1"/>
+          <p:nvPr/>
+        </p:nvSpPr>
+        <p:spPr>
+          <a:xfrm>
+            <a:off x="6172200" y="4818887"/>
+            <a:ext cx="5394960" cy="274320"/>
+          </a:xfrm>
+          <a:prstGeom prst="rect">
+            <a:avLst/>
+          </a:prstGeom>
+          <a:noFill/>
+        </p:spPr>
+        <p:txBody>
+          <a:bodyPr wrap="square" anchor="t" lIns="0" rIns="0" tIns="0" bIns="0">
+            <a:spAutoFit/>
+          </a:bodyPr>
+          <a:lstStyle/>
+          <a:p>
+            <a:pPr algn="l"/>
+            <a:r>
+              <a:rPr sz="1000" b="0">
                 <a:solidFill>
                   <a:srgbClr val="1B2C5C"/>
                 </a:solidFill>
                 <a:latin typeface="Segoe UI"/>
               </a:rPr>
-              <a:t>•  Canvas Outdoor vendor +2.9% YoY, $7.4M, 39.9% EGM, 89.1% fill</a:t>
-            </a:r>
-            <a:r>
-              <a:rPr sz="1100" b="0">
-                <a:solidFill>
-                  <a:srgbClr val="5A6B82"/>
-                </a:solidFill>
-                <a:latin typeface="Segoe UI"/>
-              </a:rPr>
-              <a:t>  — Anchor vendor performing steadily</a:t>
+              <a:t>Worst POS YoY % decline by fineline and its fill rate</a:t>
+            </a:r>
+          </a:p>
+        </p:txBody>
+      </p:sp>
+      <p:sp>
+        <p:nvSpPr>
+          <p:cNvPr id="30" name="TextBox 29"/>
+          <p:cNvSpPr txBox="1"/>
+          <p:nvPr/>
+        </p:nvSpPr>
+        <p:spPr>
+          <a:xfrm>
+            <a:off x="5806440" y="5239511"/>
+            <a:ext cx="365760" cy="274320"/>
+          </a:xfrm>
+          <a:prstGeom prst="rect">
+            <a:avLst/>
+          </a:prstGeom>
+          <a:noFill/>
+        </p:spPr>
+        <p:txBody>
+          <a:bodyPr wrap="square" anchor="t" lIns="0" rIns="0" tIns="0" bIns="0">
+            <a:spAutoFit/>
+          </a:bodyPr>
+          <a:lstStyle/>
+          <a:p>
+            <a:pPr algn="l"/>
+            <a:r>
+              <a:rPr sz="1000" b="1">
+                <a:solidFill>
+                  <a:srgbClr val="CA1A22"/>
+                </a:solidFill>
+                <a:latin typeface="Segoe UI"/>
+              </a:rPr>
+              <a:t>09</a:t>
+            </a:r>
+          </a:p>
+        </p:txBody>
+      </p:sp>
+      <p:sp>
+        <p:nvSpPr>
+          <p:cNvPr id="31" name="TextBox 30"/>
+          <p:cNvSpPr txBox="1"/>
+          <p:nvPr/>
+        </p:nvSpPr>
+        <p:spPr>
+          <a:xfrm>
+            <a:off x="6172200" y="5239511"/>
+            <a:ext cx="5394960" cy="274320"/>
+          </a:xfrm>
+          <a:prstGeom prst="rect">
+            <a:avLst/>
+          </a:prstGeom>
+          <a:noFill/>
+        </p:spPr>
+        <p:txBody>
+          <a:bodyPr wrap="square" anchor="t" lIns="0" rIns="0" tIns="0" bIns="0">
+            <a:spAutoFit/>
+          </a:bodyPr>
+          <a:lstStyle/>
+          <a:p>
+            <a:pPr algn="l"/>
+            <a:r>
+              <a:rPr sz="1000" b="0">
+                <a:solidFill>
+                  <a:srgbClr val="1B2C5C"/>
+                </a:solidFill>
+                <a:latin typeface="Segoe UI"/>
+              </a:rPr>
+              <a:t>Vendors with worst fill rate but highest planned purchase</a:t>
+            </a:r>
+          </a:p>
+        </p:txBody>
+      </p:sp>
+      <p:sp>
+        <p:nvSpPr>
+          <p:cNvPr id="32" name="TextBox 31"/>
+          <p:cNvSpPr txBox="1"/>
+          <p:nvPr/>
+        </p:nvSpPr>
+        <p:spPr>
+          <a:xfrm>
+            <a:off x="5806440" y="5660135"/>
+            <a:ext cx="365760" cy="274320"/>
+          </a:xfrm>
+          <a:prstGeom prst="rect">
+            <a:avLst/>
+          </a:prstGeom>
+          <a:noFill/>
+        </p:spPr>
+        <p:txBody>
+          <a:bodyPr wrap="square" anchor="t" lIns="0" rIns="0" tIns="0" bIns="0">
+            <a:spAutoFit/>
+          </a:bodyPr>
+          <a:lstStyle/>
+          <a:p>
+            <a:pPr algn="l"/>
+            <a:r>
+              <a:rPr sz="1000" b="1">
+                <a:solidFill>
+                  <a:srgbClr val="CA1A22"/>
+                </a:solidFill>
+                <a:latin typeface="Segoe UI"/>
+              </a:rPr>
+              <a:t>10</a:t>
+            </a:r>
+          </a:p>
+        </p:txBody>
+      </p:sp>
+      <p:sp>
+        <p:nvSpPr>
+          <p:cNvPr id="33" name="TextBox 32"/>
+          <p:cNvSpPr txBox="1"/>
+          <p:nvPr/>
+        </p:nvSpPr>
+        <p:spPr>
+          <a:xfrm>
+            <a:off x="6172200" y="5660135"/>
+            <a:ext cx="5394960" cy="274320"/>
+          </a:xfrm>
+          <a:prstGeom prst="rect">
+            <a:avLst/>
+          </a:prstGeom>
+          <a:noFill/>
+        </p:spPr>
+        <p:txBody>
+          <a:bodyPr wrap="square" anchor="t" lIns="0" rIns="0" tIns="0" bIns="0">
+            <a:spAutoFit/>
+          </a:bodyPr>
+          <a:lstStyle/>
+          <a:p>
+            <a:pPr algn="l"/>
+            <a:r>
+              <a:rPr sz="1000" b="0">
+                <a:solidFill>
+                  <a:srgbClr val="1B2C5C"/>
+                </a:solidFill>
+                <a:latin typeface="Segoe UI"/>
+              </a:rPr>
+              <a:t>Demand vs supply gap by category - where to expedite</a:t>
             </a:r>
           </a:p>
         </p:txBody>
@@ -8407,7 +9179,7 @@
                 </a:solidFill>
                 <a:latin typeface="Segoe UI"/>
               </a:rPr>
-              <a:t>Governance and trust</a:t>
+              <a:t>Headline findings from the demo data</a:t>
             </a:r>
           </a:p>
         </p:txBody>
@@ -8442,7 +9214,7 @@
                 </a:solidFill>
                 <a:latin typeface="Segoe UI"/>
               </a:rPr>
-              <a:t>Built for enterprise rollout</a:t>
+              <a:t>What Copilot surfaces in seconds</a:t>
             </a:r>
           </a:p>
         </p:txBody>
@@ -8484,14 +9256,505 @@
       </p:sp>
       <p:sp>
         <p:nvSpPr>
-          <p:cNvPr id="7" name="TextBox 6"/>
-          <p:cNvSpPr txBox="1"/>
-          <p:nvPr/>
-        </p:nvSpPr>
-        <p:spPr>
-          <a:xfrm>
-            <a:off x="640080" y="1371600"/>
-            <a:ext cx="10972800" cy="5029200"/>
+          <p:cNvPr id="7" name="Rectangle 6"/>
+          <p:cNvSpPr/>
+          <p:nvPr/>
+        </p:nvSpPr>
+        <p:spPr>
+          <a:xfrm>
+            <a:off x="457200" y="1280160"/>
+            <a:ext cx="2743200" cy="1463040"/>
+          </a:xfrm>
+          <a:prstGeom prst="rect">
+            <a:avLst/>
+          </a:prstGeom>
+          <a:solidFill>
+            <a:srgbClr val="F5F6F8"/>
+          </a:solidFill>
+          <a:ln>
+            <a:noFill/>
+          </a:ln>
+          <a:effectLst/>
+        </p:spPr>
+        <p:style>
+          <a:lnRef idx="1">
+            <a:schemeClr val="accent1"/>
+          </a:lnRef>
+          <a:fillRef idx="3">
+            <a:schemeClr val="accent1"/>
+          </a:fillRef>
+          <a:effectRef idx="2">
+            <a:schemeClr val="accent1"/>
+          </a:effectRef>
+          <a:fontRef idx="minor">
+            <a:schemeClr val="lt1"/>
+          </a:fontRef>
+        </p:style>
+        <p:txBody>
+          <a:bodyPr rtlCol="0" anchor="ctr"/>
+          <a:lstStyle/>
+          <a:p>
+            <a:pPr algn="ctr"/>
+          </a:p>
+        </p:txBody>
+      </p:sp>
+      <p:sp>
+        <p:nvSpPr>
+          <p:cNvPr id="8" name="TextBox 7"/>
+          <p:cNvSpPr txBox="1"/>
+          <p:nvPr/>
+        </p:nvSpPr>
+        <p:spPr>
+          <a:xfrm>
+            <a:off x="457200" y="1508760"/>
+            <a:ext cx="2743200" cy="640080"/>
+          </a:xfrm>
+          <a:prstGeom prst="rect">
+            <a:avLst/>
+          </a:prstGeom>
+          <a:noFill/>
+        </p:spPr>
+        <p:txBody>
+          <a:bodyPr wrap="square" anchor="ctr" lIns="0" rIns="0" tIns="0" bIns="0">
+            <a:spAutoFit/>
+          </a:bodyPr>
+          <a:lstStyle/>
+          <a:p>
+            <a:pPr algn="ctr"/>
+            <a:r>
+              <a:rPr sz="2400" b="1">
+                <a:solidFill>
+                  <a:srgbClr val="CA1A22"/>
+                </a:solidFill>
+                <a:latin typeface="Segoe UI"/>
+              </a:rPr>
+              <a:t>+27.9%</a:t>
+            </a:r>
+          </a:p>
+        </p:txBody>
+      </p:sp>
+      <p:sp>
+        <p:nvSpPr>
+          <p:cNvPr id="9" name="TextBox 8"/>
+          <p:cNvSpPr txBox="1"/>
+          <p:nvPr/>
+        </p:nvSpPr>
+        <p:spPr>
+          <a:xfrm>
+            <a:off x="457200" y="2240280"/>
+            <a:ext cx="2743200" cy="365760"/>
+          </a:xfrm>
+          <a:prstGeom prst="rect">
+            <a:avLst/>
+          </a:prstGeom>
+          <a:noFill/>
+        </p:spPr>
+        <p:txBody>
+          <a:bodyPr wrap="square" anchor="t" lIns="0" rIns="0" tIns="0" bIns="0">
+            <a:spAutoFit/>
+          </a:bodyPr>
+          <a:lstStyle/>
+          <a:p>
+            <a:pPr algn="ctr"/>
+            <a:r>
+              <a:rPr sz="1100" b="0">
+                <a:solidFill>
+                  <a:srgbClr val="5A6B82"/>
+                </a:solidFill>
+                <a:latin typeface="Segoe UI"/>
+              </a:rPr>
+              <a:t>POS YoY (Total)</a:t>
+            </a:r>
+          </a:p>
+        </p:txBody>
+      </p:sp>
+      <p:sp>
+        <p:nvSpPr>
+          <p:cNvPr id="10" name="Rectangle 9"/>
+          <p:cNvSpPr/>
+          <p:nvPr/>
+        </p:nvSpPr>
+        <p:spPr>
+          <a:xfrm>
+            <a:off x="3337560" y="1280160"/>
+            <a:ext cx="2743200" cy="1463040"/>
+          </a:xfrm>
+          <a:prstGeom prst="rect">
+            <a:avLst/>
+          </a:prstGeom>
+          <a:solidFill>
+            <a:srgbClr val="F5F6F8"/>
+          </a:solidFill>
+          <a:ln>
+            <a:noFill/>
+          </a:ln>
+          <a:effectLst/>
+        </p:spPr>
+        <p:style>
+          <a:lnRef idx="1">
+            <a:schemeClr val="accent1"/>
+          </a:lnRef>
+          <a:fillRef idx="3">
+            <a:schemeClr val="accent1"/>
+          </a:fillRef>
+          <a:effectRef idx="2">
+            <a:schemeClr val="accent1"/>
+          </a:effectRef>
+          <a:fontRef idx="minor">
+            <a:schemeClr val="lt1"/>
+          </a:fontRef>
+        </p:style>
+        <p:txBody>
+          <a:bodyPr rtlCol="0" anchor="ctr"/>
+          <a:lstStyle/>
+          <a:p>
+            <a:pPr algn="ctr"/>
+          </a:p>
+        </p:txBody>
+      </p:sp>
+      <p:sp>
+        <p:nvSpPr>
+          <p:cNvPr id="11" name="TextBox 10"/>
+          <p:cNvSpPr txBox="1"/>
+          <p:nvPr/>
+        </p:nvSpPr>
+        <p:spPr>
+          <a:xfrm>
+            <a:off x="3337560" y="1508760"/>
+            <a:ext cx="2743200" cy="640080"/>
+          </a:xfrm>
+          <a:prstGeom prst="rect">
+            <a:avLst/>
+          </a:prstGeom>
+          <a:noFill/>
+        </p:spPr>
+        <p:txBody>
+          <a:bodyPr wrap="square" anchor="ctr" lIns="0" rIns="0" tIns="0" bIns="0">
+            <a:spAutoFit/>
+          </a:bodyPr>
+          <a:lstStyle/>
+          <a:p>
+            <a:pPr algn="ctr"/>
+            <a:r>
+              <a:rPr sz="2400" b="1">
+                <a:solidFill>
+                  <a:srgbClr val="107752"/>
+                </a:solidFill>
+                <a:latin typeface="Segoe UI"/>
+              </a:rPr>
+              <a:t>42.3%</a:t>
+            </a:r>
+          </a:p>
+        </p:txBody>
+      </p:sp>
+      <p:sp>
+        <p:nvSpPr>
+          <p:cNvPr id="12" name="TextBox 11"/>
+          <p:cNvSpPr txBox="1"/>
+          <p:nvPr/>
+        </p:nvSpPr>
+        <p:spPr>
+          <a:xfrm>
+            <a:off x="3337560" y="2240280"/>
+            <a:ext cx="2743200" cy="365760"/>
+          </a:xfrm>
+          <a:prstGeom prst="rect">
+            <a:avLst/>
+          </a:prstGeom>
+          <a:noFill/>
+        </p:spPr>
+        <p:txBody>
+          <a:bodyPr wrap="square" anchor="t" lIns="0" rIns="0" tIns="0" bIns="0">
+            <a:spAutoFit/>
+          </a:bodyPr>
+          <a:lstStyle/>
+          <a:p>
+            <a:pPr algn="ctr"/>
+            <a:r>
+              <a:rPr sz="1100" b="0">
+                <a:solidFill>
+                  <a:srgbClr val="5A6B82"/>
+                </a:solidFill>
+                <a:latin typeface="Segoe UI"/>
+              </a:rPr>
+              <a:t>EGM % TY</a:t>
+            </a:r>
+          </a:p>
+        </p:txBody>
+      </p:sp>
+      <p:sp>
+        <p:nvSpPr>
+          <p:cNvPr id="13" name="Rectangle 12"/>
+          <p:cNvSpPr/>
+          <p:nvPr/>
+        </p:nvSpPr>
+        <p:spPr>
+          <a:xfrm>
+            <a:off x="6217920" y="1280160"/>
+            <a:ext cx="2743200" cy="1463040"/>
+          </a:xfrm>
+          <a:prstGeom prst="rect">
+            <a:avLst/>
+          </a:prstGeom>
+          <a:solidFill>
+            <a:srgbClr val="F5F6F8"/>
+          </a:solidFill>
+          <a:ln>
+            <a:noFill/>
+          </a:ln>
+          <a:effectLst/>
+        </p:spPr>
+        <p:style>
+          <a:lnRef idx="1">
+            <a:schemeClr val="accent1"/>
+          </a:lnRef>
+          <a:fillRef idx="3">
+            <a:schemeClr val="accent1"/>
+          </a:fillRef>
+          <a:effectRef idx="2">
+            <a:schemeClr val="accent1"/>
+          </a:effectRef>
+          <a:fontRef idx="minor">
+            <a:schemeClr val="lt1"/>
+          </a:fontRef>
+        </p:style>
+        <p:txBody>
+          <a:bodyPr rtlCol="0" anchor="ctr"/>
+          <a:lstStyle/>
+          <a:p>
+            <a:pPr algn="ctr"/>
+          </a:p>
+        </p:txBody>
+      </p:sp>
+      <p:sp>
+        <p:nvSpPr>
+          <p:cNvPr id="14" name="TextBox 13"/>
+          <p:cNvSpPr txBox="1"/>
+          <p:nvPr/>
+        </p:nvSpPr>
+        <p:spPr>
+          <a:xfrm>
+            <a:off x="6217920" y="1508760"/>
+            <a:ext cx="2743200" cy="640080"/>
+          </a:xfrm>
+          <a:prstGeom prst="rect">
+            <a:avLst/>
+          </a:prstGeom>
+          <a:noFill/>
+        </p:spPr>
+        <p:txBody>
+          <a:bodyPr wrap="square" anchor="ctr" lIns="0" rIns="0" tIns="0" bIns="0">
+            <a:spAutoFit/>
+          </a:bodyPr>
+          <a:lstStyle/>
+          <a:p>
+            <a:pPr algn="ctr"/>
+            <a:r>
+              <a:rPr sz="2400" b="1">
+                <a:solidFill>
+                  <a:srgbClr val="CC8A00"/>
+                </a:solidFill>
+                <a:latin typeface="Segoe UI"/>
+              </a:rPr>
+              <a:t>4.06%</a:t>
+            </a:r>
+          </a:p>
+        </p:txBody>
+      </p:sp>
+      <p:sp>
+        <p:nvSpPr>
+          <p:cNvPr id="15" name="TextBox 14"/>
+          <p:cNvSpPr txBox="1"/>
+          <p:nvPr/>
+        </p:nvSpPr>
+        <p:spPr>
+          <a:xfrm>
+            <a:off x="6217920" y="2240280"/>
+            <a:ext cx="2743200" cy="365760"/>
+          </a:xfrm>
+          <a:prstGeom prst="rect">
+            <a:avLst/>
+          </a:prstGeom>
+          <a:noFill/>
+        </p:spPr>
+        <p:txBody>
+          <a:bodyPr wrap="square" anchor="t" lIns="0" rIns="0" tIns="0" bIns="0">
+            <a:spAutoFit/>
+          </a:bodyPr>
+          <a:lstStyle/>
+          <a:p>
+            <a:pPr algn="ctr"/>
+            <a:r>
+              <a:rPr sz="1100" b="0">
+                <a:solidFill>
+                  <a:srgbClr val="5A6B82"/>
+                </a:solidFill>
+                <a:latin typeface="Segoe UI"/>
+              </a:rPr>
+              <a:t>Avg Lost Sales</a:t>
+            </a:r>
+          </a:p>
+        </p:txBody>
+      </p:sp>
+      <p:sp>
+        <p:nvSpPr>
+          <p:cNvPr id="16" name="Rectangle 15"/>
+          <p:cNvSpPr/>
+          <p:nvPr/>
+        </p:nvSpPr>
+        <p:spPr>
+          <a:xfrm>
+            <a:off x="9098280" y="1280160"/>
+            <a:ext cx="2743200" cy="1463040"/>
+          </a:xfrm>
+          <a:prstGeom prst="rect">
+            <a:avLst/>
+          </a:prstGeom>
+          <a:solidFill>
+            <a:srgbClr val="F5F6F8"/>
+          </a:solidFill>
+          <a:ln>
+            <a:noFill/>
+          </a:ln>
+          <a:effectLst/>
+        </p:spPr>
+        <p:style>
+          <a:lnRef idx="1">
+            <a:schemeClr val="accent1"/>
+          </a:lnRef>
+          <a:fillRef idx="3">
+            <a:schemeClr val="accent1"/>
+          </a:fillRef>
+          <a:effectRef idx="2">
+            <a:schemeClr val="accent1"/>
+          </a:effectRef>
+          <a:fontRef idx="minor">
+            <a:schemeClr val="lt1"/>
+          </a:fontRef>
+        </p:style>
+        <p:txBody>
+          <a:bodyPr rtlCol="0" anchor="ctr"/>
+          <a:lstStyle/>
+          <a:p>
+            <a:pPr algn="ctr"/>
+          </a:p>
+        </p:txBody>
+      </p:sp>
+      <p:sp>
+        <p:nvSpPr>
+          <p:cNvPr id="17" name="TextBox 16"/>
+          <p:cNvSpPr txBox="1"/>
+          <p:nvPr/>
+        </p:nvSpPr>
+        <p:spPr>
+          <a:xfrm>
+            <a:off x="9098280" y="1508760"/>
+            <a:ext cx="2743200" cy="640080"/>
+          </a:xfrm>
+          <a:prstGeom prst="rect">
+            <a:avLst/>
+          </a:prstGeom>
+          <a:noFill/>
+        </p:spPr>
+        <p:txBody>
+          <a:bodyPr wrap="square" anchor="ctr" lIns="0" rIns="0" tIns="0" bIns="0">
+            <a:spAutoFit/>
+          </a:bodyPr>
+          <a:lstStyle/>
+          <a:p>
+            <a:pPr algn="ctr"/>
+            <a:r>
+              <a:rPr sz="2400" b="1">
+                <a:solidFill>
+                  <a:srgbClr val="CA1A22"/>
+                </a:solidFill>
+                <a:latin typeface="Segoe UI"/>
+              </a:rPr>
+              <a:t>89.0%</a:t>
+            </a:r>
+          </a:p>
+        </p:txBody>
+      </p:sp>
+      <p:sp>
+        <p:nvSpPr>
+          <p:cNvPr id="18" name="TextBox 17"/>
+          <p:cNvSpPr txBox="1"/>
+          <p:nvPr/>
+        </p:nvSpPr>
+        <p:spPr>
+          <a:xfrm>
+            <a:off x="9098280" y="2240280"/>
+            <a:ext cx="2743200" cy="365760"/>
+          </a:xfrm>
+          <a:prstGeom prst="rect">
+            <a:avLst/>
+          </a:prstGeom>
+          <a:noFill/>
+        </p:spPr>
+        <p:txBody>
+          <a:bodyPr wrap="square" anchor="t" lIns="0" rIns="0" tIns="0" bIns="0">
+            <a:spAutoFit/>
+          </a:bodyPr>
+          <a:lstStyle/>
+          <a:p>
+            <a:pPr algn="ctr"/>
+            <a:r>
+              <a:rPr sz="1100" b="0">
+                <a:solidFill>
+                  <a:srgbClr val="5A6B82"/>
+                </a:solidFill>
+                <a:latin typeface="Segoe UI"/>
+              </a:rPr>
+              <a:t>Vendor Fill Rate</a:t>
+            </a:r>
+          </a:p>
+        </p:txBody>
+      </p:sp>
+      <p:sp>
+        <p:nvSpPr>
+          <p:cNvPr id="19" name="TextBox 18"/>
+          <p:cNvSpPr txBox="1"/>
+          <p:nvPr/>
+        </p:nvSpPr>
+        <p:spPr>
+          <a:xfrm>
+            <a:off x="457200" y="2926080"/>
+            <a:ext cx="11247120" cy="365760"/>
+          </a:xfrm>
+          <a:prstGeom prst="rect">
+            <a:avLst/>
+          </a:prstGeom>
+          <a:noFill/>
+        </p:spPr>
+        <p:txBody>
+          <a:bodyPr wrap="square" anchor="t" lIns="0" rIns="0" tIns="0" bIns="0">
+            <a:spAutoFit/>
+          </a:bodyPr>
+          <a:lstStyle/>
+          <a:p>
+            <a:pPr algn="l"/>
+            <a:r>
+              <a:rPr sz="1400" b="1">
+                <a:solidFill>
+                  <a:srgbClr val="CA1A22"/>
+                </a:solidFill>
+                <a:latin typeface="Segoe UI"/>
+              </a:rPr>
+              <a:t>Insights merchants can act on</a:t>
+            </a:r>
+          </a:p>
+        </p:txBody>
+      </p:sp>
+      <p:sp>
+        <p:nvSpPr>
+          <p:cNvPr id="20" name="TextBox 19"/>
+          <p:cNvSpPr txBox="1"/>
+          <p:nvPr/>
+        </p:nvSpPr>
+        <p:spPr>
+          <a:xfrm>
+            <a:off x="457200" y="3337560"/>
+            <a:ext cx="11247120" cy="3200400"/>
           </a:xfrm>
           <a:prstGeom prst="rect">
             <a:avLst/>
@@ -8510,22 +9773,22 @@
               </a:lnSpc>
             </a:pPr>
             <a:r>
-              <a:rPr sz="1300" b="1">
+              <a:rPr sz="1200" b="1">
                 <a:solidFill>
                   <a:srgbClr val="1B2C5C"/>
                 </a:solidFill>
                 <a:latin typeface="Segoe UI"/>
               </a:rPr>
-              <a:t>•  PII handling</a:t>
-            </a:r>
-            <a:r>
-              <a:rPr sz="1200" b="0">
+              <a:t>•  Air Fryers +88.7% YoY POS</a:t>
+            </a:r>
+            <a:r>
+              <a:rPr sz="1100" b="0">
                 <a:solidFill>
                   <a:srgbClr val="5A6B82"/>
                 </a:solidFill>
                 <a:latin typeface="Segoe UI"/>
               </a:rPr>
-              <a:t>  — Copilot in PBI does not send PII outside the M365 service boundary. Sensitivity labels and Purview classification carry through.</a:t>
+              <a:t>  — Strongest growth fineline - protect supply, expand assortment</a:t>
             </a:r>
           </a:p>
           <a:p>
@@ -8535,22 +9798,22 @@
               </a:lnSpc>
             </a:pPr>
             <a:r>
-              <a:rPr sz="1300" b="1">
+              <a:rPr sz="1200" b="1">
                 <a:solidFill>
                   <a:srgbClr val="1B2C5C"/>
                 </a:solidFill>
                 <a:latin typeface="Segoe UI"/>
               </a:rPr>
-              <a:t>•  Data residency</a:t>
-            </a:r>
-            <a:r>
-              <a:rPr sz="1200" b="0">
+              <a:t>•  NK Dual Zone Air Fryer 8L losing 13.7% of demand</a:t>
+            </a:r>
+            <a:r>
+              <a:rPr sz="1100" b="0">
                 <a:solidFill>
                   <a:srgbClr val="5A6B82"/>
                 </a:solidFill>
                 <a:latin typeface="Segoe UI"/>
               </a:rPr>
-              <a:t>  — Canadian Tire is on Canada-resident Fabric capacity. Copilot processing stays within the M365 geo of your tenant.</a:t>
+              <a:t>  — Vendor fill rate only 72.7% - immediate supply intervention</a:t>
             </a:r>
           </a:p>
           <a:p>
@@ -8560,22 +9823,22 @@
               </a:lnSpc>
             </a:pPr>
             <a:r>
-              <a:rPr sz="1300" b="1">
+              <a:rPr sz="1200" b="1">
                 <a:solidFill>
                   <a:srgbClr val="1B2C5C"/>
                 </a:solidFill>
                 <a:latin typeface="Segoe UI"/>
               </a:rPr>
-              <a:t>•  Conversation retention</a:t>
-            </a:r>
-            <a:r>
-              <a:rPr sz="1200" b="0">
+              <a:t>•  9 SKUs WoS &gt; 18 with low lost sales</a:t>
+            </a:r>
+            <a:r>
+              <a:rPr sz="1100" b="0">
                 <a:solidFill>
                   <a:srgbClr val="5A6B82"/>
                 </a:solidFill>
                 <a:latin typeface="Segoe UI"/>
               </a:rPr>
-              <a:t>  — Prompt and response history governed by M365 admin retention policies. No model training on your data.</a:t>
+              <a:t>  — Classic markdown / promo candidates - sell-through stalled</a:t>
             </a:r>
           </a:p>
           <a:p>
@@ -8585,22 +9848,22 @@
               </a:lnSpc>
             </a:pPr>
             <a:r>
-              <a:rPr sz="1300" b="1">
+              <a:rPr sz="1200" b="1">
                 <a:solidFill>
                   <a:srgbClr val="1B2C5C"/>
                 </a:solidFill>
                 <a:latin typeface="Segoe UI"/>
               </a:rPr>
-              <a:t>•  Purview DLP</a:t>
-            </a:r>
-            <a:r>
-              <a:rPr sz="1200" b="0">
+              <a:t>•  OL-BBQ-003 (Woodfire Grill) +1671% YoY</a:t>
+            </a:r>
+            <a:r>
+              <a:rPr sz="1100" b="0">
                 <a:solidFill>
                   <a:srgbClr val="5A6B82"/>
                 </a:solidFill>
                 <a:latin typeface="Segoe UI"/>
               </a:rPr>
-              <a:t>  — Existing DLP policies apply to Copilot interactions, including blocked sharing of sensitive content.</a:t>
+              <a:t>  — New SKU with strong demand but fill rate 71% - over-rotate on PO</a:t>
             </a:r>
           </a:p>
           <a:p>
@@ -8610,47 +9873,22 @@
               </a:lnSpc>
             </a:pPr>
             <a:r>
-              <a:rPr sz="1300" b="1">
+              <a:rPr sz="1200" b="1">
                 <a:solidFill>
                   <a:srgbClr val="1B2C5C"/>
                 </a:solidFill>
                 <a:latin typeface="Segoe UI"/>
               </a:rPr>
-              <a:t>•  Responsible AI</a:t>
-            </a:r>
-            <a:r>
-              <a:rPr sz="1200" b="0">
+              <a:t>•  Canvas Outdoor vendor +2.9% YoY, $7.4M, 39.9% EGM, 89.1% fill</a:t>
+            </a:r>
+            <a:r>
+              <a:rPr sz="1100" b="0">
                 <a:solidFill>
                   <a:srgbClr val="5A6B82"/>
                 </a:solidFill>
                 <a:latin typeface="Segoe UI"/>
               </a:rPr>
-              <a:t>  — Aligned with Microsoft Responsible AI Standard - groundedness, safety filters, attribution.</a:t>
-            </a:r>
-          </a:p>
-          <a:p>
-            <a:pPr>
-              <a:lnSpc>
-                <a:spcPct val="115000"/>
-              </a:lnSpc>
-            </a:pPr>
-            <a:r>
-              <a:rPr sz="1300" b="1">
-                <a:solidFill>
-                  <a:srgbClr val="1B2C5C"/>
-                </a:solidFill>
-                <a:latin typeface="Segoe UI"/>
-              </a:rPr>
-              <a:t>•  Audit and observability</a:t>
-            </a:r>
-            <a:r>
-              <a:rPr sz="1200" b="0">
-                <a:solidFill>
-                  <a:srgbClr val="5A6B82"/>
-                </a:solidFill>
-                <a:latin typeface="Segoe UI"/>
-              </a:rPr>
-              <a:t>  — Copilot usage logged in M365 audit log, viewable via Purview eDiscovery.</a:t>
+              <a:t>  — Anchor vendor performing steadily</a:t>
             </a:r>
           </a:p>
         </p:txBody>
@@ -8791,7 +10029,7 @@
                 </a:solidFill>
                 <a:latin typeface="Segoe UI"/>
               </a:rPr>
-              <a:t>Roadmap</a:t>
+              <a:t>Governance and trust</a:t>
             </a:r>
           </a:p>
         </p:txBody>
@@ -8826,7 +10064,7 @@
                 </a:solidFill>
                 <a:latin typeface="Segoe UI"/>
               </a:rPr>
-              <a:t>Where Copilot in Power BI is going</a:t>
+              <a:t>Built for enterprise rollout</a:t>
             </a:r>
           </a:p>
         </p:txBody>
@@ -8900,7 +10138,7 @@
                 </a:solidFill>
                 <a:latin typeface="Segoe UI"/>
               </a:rPr>
-              <a:t>•  GA today</a:t>
+              <a:t>•  PII handling</a:t>
             </a:r>
             <a:r>
               <a:rPr sz="1200" b="0">
@@ -8909,7 +10147,7 @@
                 </a:solidFill>
                 <a:latin typeface="Segoe UI"/>
               </a:rPr>
-              <a:t>  — Summarize page, Q&amp;A, Smart Narrative, Find Insights, anomaly explanations</a:t>
+              <a:t>  — Copilot in PBI does not send PII outside the M365 service boundary. Sensitivity labels and Purview classification carry through.</a:t>
             </a:r>
           </a:p>
           <a:p>
@@ -8925,7 +10163,7 @@
                 </a:solidFill>
                 <a:latin typeface="Segoe UI"/>
               </a:rPr>
-              <a:t>•  Recent additions</a:t>
+              <a:t>•  Data residency</a:t>
             </a:r>
             <a:r>
               <a:rPr sz="1200" b="0">
@@ -8934,7 +10172,7 @@
                 </a:solidFill>
                 <a:latin typeface="Segoe UI"/>
               </a:rPr>
-              <a:t>  — Cross-report grounding, custom semantic model instructions, multi-turn Q&amp;A</a:t>
+              <a:t>  — Canadian Tire is on Canada-resident Fabric capacity. Copilot processing stays within the M365 geo of your tenant.</a:t>
             </a:r>
           </a:p>
           <a:p>
@@ -8950,7 +10188,7 @@
                 </a:solidFill>
                 <a:latin typeface="Segoe UI"/>
               </a:rPr>
-              <a:t>•  Near-term (next 90 days)</a:t>
+              <a:t>•  Conversation retention</a:t>
             </a:r>
             <a:r>
               <a:rPr sz="1200" b="0">
@@ -8959,7 +10197,7 @@
                 </a:solidFill>
                 <a:latin typeface="Segoe UI"/>
               </a:rPr>
-              <a:t>  — Agent-style follow-ups, deeper drill into measure lineage, custom example prompts at workspace scope</a:t>
+              <a:t>  — Prompt and response history governed by M365 admin retention policies. No model training on your data.</a:t>
             </a:r>
           </a:p>
           <a:p>
@@ -8975,7 +10213,7 @@
                 </a:solidFill>
                 <a:latin typeface="Segoe UI"/>
               </a:rPr>
-              <a:t>•  Integration story</a:t>
+              <a:t>•  Purview DLP</a:t>
             </a:r>
             <a:r>
               <a:rPr sz="1200" b="0">
@@ -8984,7 +10222,7 @@
                 </a:solidFill>
                 <a:latin typeface="Segoe UI"/>
               </a:rPr>
-              <a:t>  — Fabric Data Agent, Copilot Studio agents, Teams + Outlook + Word surfaces</a:t>
+              <a:t>  — Existing DLP policies apply to Copilot interactions, including blocked sharing of sensitive content.</a:t>
             </a:r>
           </a:p>
           <a:p>
@@ -9000,7 +10238,7 @@
                 </a:solidFill>
                 <a:latin typeface="Segoe UI"/>
               </a:rPr>
-              <a:t>•  CTC-specific opportunities</a:t>
+              <a:t>•  Responsible AI</a:t>
             </a:r>
             <a:r>
               <a:rPr sz="1200" b="0">
@@ -9009,7 +10247,32 @@
                 </a:solidFill>
                 <a:latin typeface="Segoe UI"/>
               </a:rPr>
-              <a:t>  — Workspace-scoped Copilot for Merch, finance-team scope (separate effort), supply-chain agent on Connected Inventory</a:t>
+              <a:t>  — Aligned with Microsoft Responsible AI Standard - groundedness, safety filters, attribution.</a:t>
+            </a:r>
+          </a:p>
+          <a:p>
+            <a:pPr>
+              <a:lnSpc>
+                <a:spcPct val="115000"/>
+              </a:lnSpc>
+            </a:pPr>
+            <a:r>
+              <a:rPr sz="1300" b="1">
+                <a:solidFill>
+                  <a:srgbClr val="1B2C5C"/>
+                </a:solidFill>
+                <a:latin typeface="Segoe UI"/>
+              </a:rPr>
+              <a:t>•  Audit and observability</a:t>
+            </a:r>
+            <a:r>
+              <a:rPr sz="1200" b="0">
+                <a:solidFill>
+                  <a:srgbClr val="5A6B82"/>
+                </a:solidFill>
+                <a:latin typeface="Segoe UI"/>
+              </a:rPr>
+              <a:t>  — Copilot usage logged in M365 audit log, viewable via Purview eDiscovery.</a:t>
             </a:r>
           </a:p>
         </p:txBody>

</xml_diff>